<commit_message>
modify lab3.ipynb and pptx
</commit_message>
<xml_diff>
--- a/3일차_실습3_latest.pptx
+++ b/3일차_실습3_latest.pptx
@@ -27346,51 +27346,7 @@
                 <a:ea typeface="Consolas" pitchFamily="34" charset="-122"/>
                 <a:cs typeface="Consolas" pitchFamily="34" charset="-120"/>
               </a:rPr>
-              <a:t>= '</a:t>
-            </a:r>
-            <a:r>
-              <a:rPr lang="ko-KR" altLang="en-US" sz="950" dirty="0">
-                <a:solidFill>
-                  <a:srgbClr val="E6EDF3"/>
-                </a:solidFill>
-                <a:latin typeface="Consolas" pitchFamily="34" charset="0"/>
-                <a:ea typeface="Consolas" pitchFamily="34" charset="-122"/>
-                <a:cs typeface="Consolas" pitchFamily="34" charset="-120"/>
-              </a:rPr>
-              <a:t>❌ </a:t>
-            </a:r>
-            <a:r>
-              <a:rPr lang="es-419" altLang="ko-KR" sz="950" dirty="0">
-                <a:solidFill>
-                  <a:srgbClr val="E6EDF3"/>
-                </a:solidFill>
-                <a:latin typeface="Consolas" pitchFamily="34" charset="0"/>
-                <a:ea typeface="Consolas" pitchFamily="34" charset="-122"/>
-                <a:cs typeface="Consolas" pitchFamily="34" charset="-120"/>
-              </a:rPr>
-              <a:t>FAIL' if data['fails'] &gt; 0 else '</a:t>
-            </a:r>
-            <a:r>
-              <a:rPr lang="ko-KR" altLang="en-US" sz="950" dirty="0">
-                <a:solidFill>
-                  <a:srgbClr val="E6EDF3"/>
-                </a:solidFill>
-                <a:latin typeface="Consolas" pitchFamily="34" charset="0"/>
-                <a:ea typeface="Consolas" pitchFamily="34" charset="-122"/>
-                <a:cs typeface="Consolas" pitchFamily="34" charset="-120"/>
-              </a:rPr>
-              <a:t>✅ </a:t>
-            </a:r>
-            <a:r>
-              <a:rPr lang="es-419" altLang="ko-KR" sz="950" dirty="0">
-                <a:solidFill>
-                  <a:srgbClr val="E6EDF3"/>
-                </a:solidFill>
-                <a:latin typeface="Consolas" pitchFamily="34" charset="0"/>
-                <a:ea typeface="Consolas" pitchFamily="34" charset="-122"/>
-                <a:cs typeface="Consolas" pitchFamily="34" charset="-120"/>
-              </a:rPr>
-              <a:t>PASS＇</a:t>
+              <a:t>= 'FAIL' if data['fails'] &gt; 0 else 'PASS＇</a:t>
             </a:r>
           </a:p>
           <a:p>

</xml_diff>